<commit_message>
Update ParaRNN slides after narrative pass.
Tighten Newton convergence, diagonalization critique, and asymptotics
wording; refresh PDF/PPTX exports.
</commit_message>
<xml_diff>
--- a/presentation/ParaRNN-draft.pptx
+++ b/presentation/ParaRNN-draft.pptx
@@ -1144,7 +1144,7 @@
           <a:lstStyle/>
           <a:p>
             <a:r>
-              <a:t>Эмпирика сходимости.</a:t>
+              <a:t>Теория: N_its ≪ L/log L; практика: 3 шага на Para*/7B.</a:t>
             </a:r>
           </a:p>
         </p:txBody>
@@ -1214,7 +1214,7 @@
           <a:lstStyle/>
           <a:p>
             <a:r>
-              <a:t>Флагманский слайд: W_h → diag → 2×2 → MLP.</a:t>
+              <a:t>Выигрыш O(d_h) в тексте; критика: изоляция каналов / слабость синтетики.</a:t>
             </a:r>
           </a:p>
         </p:txBody>
@@ -7724,7 +7724,7 @@
                 </a:solidFill>
                 <a:latin typeface="Calibri"/>
               </a:rPr>
-              <a:t>Сходимость Ньютона</a:t>
+              <a:t>Сходимость метода Ньютона</a:t>
             </a:r>
           </a:p>
         </p:txBody>
@@ -7737,8 +7737,8 @@
         </p:nvSpPr>
         <p:spPr>
           <a:xfrm>
-            <a:off x="502920" y="960120"/>
-            <a:ext cx="11155680" cy="5029200"/>
+            <a:off x="502920" y="777240"/>
+            <a:ext cx="11155680" cy="5303520"/>
           </a:xfrm>
           <a:prstGeom prst="rect">
             <a:avLst/>
@@ -7757,13 +7757,13 @@
               </a:spcAft>
             </a:pPr>
             <a:r>
-              <a:rPr sz="1600" b="0">
+              <a:rPr sz="1300" b="0">
                 <a:solidFill>
                   <a:srgbClr val="0F2744"/>
                 </a:solidFill>
                 <a:latin typeface="Calibri"/>
               </a:rPr>
-              <a:t>У ParaGRU и ParaLSTM норма ||F||_∞ падает до машинной точности (10⁻⁵–10⁻⁶) за три–четыре шага как до обучения, так и после него.</a:t>
+              <a:t>Условие выигрыша по времени. Параллельный солвер быстрее последовательного прохода O(L), пока N_its ≪ L / log₂ L.</a:t>
             </a:r>
           </a:p>
           <a:p>
@@ -7773,13 +7773,13 @@
               </a:spcAft>
             </a:pPr>
             <a:r>
-              <a:rPr sz="1600" b="0">
+              <a:rPr sz="1300" b="0">
                 <a:solidFill>
                   <a:srgbClr val="0F2744"/>
                 </a:solidFill>
                 <a:latin typeface="Calibri"/>
               </a:rPr>
-              <a:t>• длины в проверках: L ∈ {2⁸,…,2¹¹}</a:t>
+              <a:t>Запас большой: даже при N_its ∼ O(log L) глубина O(log² L) асимптотически обгоняет последовательную развёртку.</a:t>
             </a:r>
           </a:p>
           <a:p>
@@ -7789,13 +7789,13 @@
               </a:spcAft>
             </a:pPr>
             <a:r>
-              <a:rPr sz="1600" b="0">
+              <a:rPr sz="1300" b="0">
                 <a:solidFill>
                   <a:srgbClr val="0F2744"/>
                 </a:solidFill>
                 <a:latin typeface="Calibri"/>
               </a:rPr>
-              <a:t>• бюджет итераций в экспериментах: N_its = 3</a:t>
+              <a:t>Эмпирическая сходимость в статье (рис. 4). На практике запас почти не расходуется:</a:t>
             </a:r>
           </a:p>
           <a:p>
@@ -7805,13 +7805,13 @@
               </a:spcAft>
             </a:pPr>
             <a:r>
-              <a:rPr sz="1600" b="0">
+              <a:rPr sz="1300" b="0">
                 <a:solidFill>
                   <a:srgbClr val="0F2744"/>
                 </a:solidFill>
                 <a:latin typeface="Calibri"/>
               </a:rPr>
-              <a:t>• условие выгодности: N_its*(L) ≪ L</a:t>
+              <a:t>• ||F||_∞ падает до машинной точности (10⁻⁵–10⁻⁶) за 3 шага;</a:t>
             </a:r>
           </a:p>
           <a:p>
@@ -7821,13 +7821,61 @@
               </a:spcAft>
             </a:pPr>
             <a:r>
-              <a:rPr sz="1600" b="0">
+              <a:rPr sz="1300" b="0">
                 <a:solidFill>
                   <a:srgbClr val="0F2744"/>
                 </a:solidFill>
                 <a:latin typeface="Calibri"/>
               </a:rPr>
-              <a:t>Для произвольной нелинейной ячейки такой лимит заранее не гарантирован: число итераций метода Ньютона может расти вместе с L.</a:t>
+              <a:t>• скорость сходимости инвариантна к длине: кривые для L=2⁸ и L=2¹¹ накладываются;</a:t>
+            </a:r>
+          </a:p>
+          <a:p>
+            <a:pPr>
+              <a:spcAft>
+                <a:spcPts val="800"/>
+              </a:spcAft>
+            </a:pPr>
+            <a:r>
+              <a:rPr sz="1300" b="0">
+                <a:solidFill>
+                  <a:srgbClr val="0F2744"/>
+                </a:solidFill>
+                <a:latin typeface="Calibri"/>
+              </a:rPr>
+              <a:t>• поведение устойчиво на случайных весах и на обученных моделях до 7B.</a:t>
+            </a:r>
+          </a:p>
+          <a:p>
+            <a:pPr>
+              <a:spcAft>
+                <a:spcPts val="800"/>
+              </a:spcAft>
+            </a:pPr>
+            <a:r>
+              <a:rPr sz="1300" b="0">
+                <a:solidFill>
+                  <a:srgbClr val="0F2744"/>
+                </a:solidFill>
+                <a:latin typeface="Calibri"/>
+              </a:rPr>
+              <a:t>Для обучения фиксируется константный бюджет N_its = 3.</a:t>
+            </a:r>
+          </a:p>
+          <a:p>
+            <a:pPr>
+              <a:spcAft>
+                <a:spcPts val="800"/>
+              </a:spcAft>
+            </a:pPr>
+            <a:r>
+              <a:rPr sz="1300" b="0">
+                <a:solidFill>
+                  <a:srgbClr val="0F2744"/>
+                </a:solidFill>
+                <a:latin typeface="Calibri"/>
+              </a:rPr>
+              <a:t>Оговорка. Сходимость за 3 шага обеспечена диагональной структурой ячеек и сжатием весов (|a_*| ≤ 0,5). Для произвольных новых RNN нужна отдельная валидация.</a:t>
             </a:r>
           </a:p>
         </p:txBody>
@@ -7887,7 +7935,7 @@
                 </a:solidFill>
                 <a:latin typeface="Calibri"/>
               </a:rPr>
-              <a:t>Диагонализация A_*</a:t>
+              <a:t>Диагонализация матриц перехода: путь к O(d_h)</a:t>
             </a:r>
           </a:p>
         </p:txBody>
@@ -7900,8 +7948,8 @@
         </p:nvSpPr>
         <p:spPr>
           <a:xfrm>
-            <a:off x="502920" y="822960"/>
-            <a:ext cx="11155680" cy="2331720"/>
+            <a:off x="502920" y="777240"/>
+            <a:ext cx="11155680" cy="5303520"/>
           </a:xfrm>
           <a:prstGeom prst="rect">
             <a:avLst/>
@@ -7926,7 +7974,7 @@
                 </a:solidFill>
                 <a:latin typeface="Calibri"/>
               </a:rPr>
-              <a:t>Узкое место: в GRU/LSTM есть W_h h_{l−1}, блоки J_f плотные размера d_h×d_h; скан даёт O(L d_h²) памяти и O(d_h³) на умножение блока.</a:t>
+              <a:t>Проблема. В LSTM/GRU состояния смешиваются плотными матрицами; в скане это O(L d_h²) памяти и O(d_h³) на шаг редукции.</a:t>
             </a:r>
           </a:p>
           <a:p>
@@ -7942,7 +7990,7 @@
                 </a:solidFill>
                 <a:latin typeface="Calibri"/>
               </a:rPr>
-              <a:t>Ключевая модификация — замена плотного умножения на поэлементное гейтирование. (6)  A_*=diag(a_*), C_*=diag(c_*); a_*,c_* ∈ R^{d_h}.</a:t>
+              <a:t>Решение (6): A_*=diag(a_*), C_*=diag(c_*). У ParaGRU якобиан диагонален, у ParaLSTM — блочно-диагональный 2×2, уменьшая расходы памяти с O(L d_h²) до O(L d_h) и критически снижая сложность вычислений с O(d_h³) до O(d_h).</a:t>
             </a:r>
           </a:p>
           <a:p>
@@ -7958,7 +8006,7 @@
                 </a:solidFill>
                 <a:latin typeface="Calibri"/>
               </a:rPr>
-              <a:t>• у ParaGRU якобиан J_f чисто диагонален</a:t>
+              <a:t>Уязвимость в аргументации авторов:</a:t>
             </a:r>
           </a:p>
           <a:p>
@@ -7974,7 +8022,7 @@
                 </a:solidFill>
                 <a:latin typeface="Calibri"/>
               </a:rPr>
-              <a:t>• у ParaLSTM из-за связки (c_l, h_l) остаются блоки 2×2 с диагональными множителями</a:t>
+              <a:t>• Диагонализация даёт d_h изолированных 1D-рекуррентностей — каналы во времени не взаимодействуют напрямую.</a:t>
             </a:r>
           </a:p>
           <a:p>
@@ -7990,253 +8038,9 @@
                 </a:solidFill>
                 <a:latin typeface="Calibri"/>
               </a:rPr>
-              <a:t>• смешивание каналов во времени переносится в MLP между слоями</a:t>
-            </a:r>
-          </a:p>
-        </p:txBody>
-      </p:sp>
-      <p:graphicFrame>
-        <p:nvGraphicFramePr>
-          <p:cNvPr id="4" name="Table 3"/>
-          <p:cNvGraphicFramePr>
-            <a:graphicFrameLocks noGrp="1"/>
-          </p:cNvGraphicFramePr>
-          <p:nvPr/>
-        </p:nvGraphicFramePr>
-        <p:xfrm>
-          <a:off x="502920" y="3246120"/>
-          <a:ext cx="11155680" cy="1417320"/>
-        </p:xfrm>
-        <a:graphic>
-          <a:graphicData uri="http://schemas.openxmlformats.org/drawingml/2006/table">
-            <a:tbl>
-              <a:tblPr firstRow="1" bandRow="1">
-                <a:tableStyleId>{5C22544A-7EE6-4342-B048-85BDC9FD1C3A}</a:tableStyleId>
-              </a:tblPr>
-              <a:tblGrid>
-                <a:gridCol w="3718560"/>
-                <a:gridCol w="3718560"/>
-                <a:gridCol w="3718560"/>
-              </a:tblGrid>
-              <a:tr h="472440">
-                <a:tc>
-                  <a:txBody>
-                    <a:bodyPr/>
-                    <a:lstStyle/>
-                    <a:p/>
-                  </a:txBody>
-                  <a:tcPr anchor="ctr">
-                    <a:solidFill>
-                      <a:srgbClr val="1F4E79"/>
-                    </a:solidFill>
-                  </a:tcPr>
-                </a:tc>
-                <a:tc>
-                  <a:txBody>
-                    <a:bodyPr/>
-                    <a:lstStyle/>
-                    <a:p>
-                      <a:r>
-                        <a:rPr sz="1500" b="1">
-                          <a:solidFill>
-                            <a:srgbClr val="FFFFFF"/>
-                          </a:solidFill>
-                          <a:latin typeface="Calibri"/>
-                        </a:rPr>
-                        <a:t>Плотные A_*</a:t>
-                      </a:r>
-                    </a:p>
-                  </a:txBody>
-                  <a:tcPr anchor="ctr">
-                    <a:solidFill>
-                      <a:srgbClr val="1F4E79"/>
-                    </a:solidFill>
-                  </a:tcPr>
-                </a:tc>
-                <a:tc>
-                  <a:txBody>
-                    <a:bodyPr/>
-                    <a:lstStyle/>
-                    <a:p>
-                      <a:r>
-                        <a:rPr sz="1500" b="1">
-                          <a:solidFill>
-                            <a:srgbClr val="FFFFFF"/>
-                          </a:solidFill>
-                          <a:latin typeface="Calibri"/>
-                        </a:rPr>
-                        <a:t>Диаг. A_*</a:t>
-                      </a:r>
-                    </a:p>
-                  </a:txBody>
-                  <a:tcPr anchor="ctr">
-                    <a:solidFill>
-                      <a:srgbClr val="1F4E79"/>
-                    </a:solidFill>
-                  </a:tcPr>
-                </a:tc>
-              </a:tr>
-              <a:tr h="472440">
-                <a:tc>
-                  <a:txBody>
-                    <a:bodyPr/>
-                    <a:lstStyle/>
-                    <a:p>
-                      <a:r>
-                        <a:rPr sz="1500" b="0">
-                          <a:solidFill>
-                            <a:srgbClr val="0F2744"/>
-                          </a:solidFill>
-                          <a:latin typeface="Calibri"/>
-                        </a:rPr>
-                        <a:t>Память</a:t>
-                      </a:r>
-                    </a:p>
-                  </a:txBody>
-                  <a:tcPr anchor="ctr">
-                    <a:solidFill>
-                      <a:srgbClr val="F3F6FA"/>
-                    </a:solidFill>
-                  </a:tcPr>
-                </a:tc>
-                <a:tc>
-                  <a:txBody>
-                    <a:bodyPr/>
-                    <a:lstStyle/>
-                    <a:p>
-                      <a:r>
-                        <a:rPr sz="1500" b="0">
-                          <a:solidFill>
-                            <a:srgbClr val="0F2744"/>
-                          </a:solidFill>
-                          <a:latin typeface="Calibri"/>
-                        </a:rPr>
-                        <a:t>O(L d_h²)</a:t>
-                      </a:r>
-                    </a:p>
-                  </a:txBody>
-                  <a:tcPr anchor="ctr">
-                    <a:solidFill>
-                      <a:srgbClr val="F3F6FA"/>
-                    </a:solidFill>
-                  </a:tcPr>
-                </a:tc>
-                <a:tc>
-                  <a:txBody>
-                    <a:bodyPr/>
-                    <a:lstStyle/>
-                    <a:p>
-                      <a:r>
-                        <a:rPr sz="1500" b="0">
-                          <a:solidFill>
-                            <a:srgbClr val="0F2744"/>
-                          </a:solidFill>
-                          <a:latin typeface="Calibri"/>
-                        </a:rPr>
-                        <a:t>O(L d_h)</a:t>
-                      </a:r>
-                    </a:p>
-                  </a:txBody>
-                  <a:tcPr anchor="ctr">
-                    <a:solidFill>
-                      <a:srgbClr val="F3F6FA"/>
-                    </a:solidFill>
-                  </a:tcPr>
-                </a:tc>
-              </a:tr>
-              <a:tr h="472440">
-                <a:tc>
-                  <a:txBody>
-                    <a:bodyPr/>
-                    <a:lstStyle/>
-                    <a:p>
-                      <a:r>
-                        <a:rPr sz="1500" b="0">
-                          <a:solidFill>
-                            <a:srgbClr val="0F2744"/>
-                          </a:solidFill>
-                          <a:latin typeface="Calibri"/>
-                        </a:rPr>
-                        <a:t>Умножение</a:t>
-                      </a:r>
-                    </a:p>
-                  </a:txBody>
-                  <a:tcPr anchor="ctr">
-                    <a:solidFill>
-                      <a:srgbClr val="FFFFFF"/>
-                    </a:solidFill>
-                  </a:tcPr>
-                </a:tc>
-                <a:tc>
-                  <a:txBody>
-                    <a:bodyPr/>
-                    <a:lstStyle/>
-                    <a:p>
-                      <a:r>
-                        <a:rPr sz="1500" b="0">
-                          <a:solidFill>
-                            <a:srgbClr val="0F2744"/>
-                          </a:solidFill>
-                          <a:latin typeface="Calibri"/>
-                        </a:rPr>
-                        <a:t>O(d_h³)</a:t>
-                      </a:r>
-                    </a:p>
-                  </a:txBody>
-                  <a:tcPr anchor="ctr">
-                    <a:solidFill>
-                      <a:srgbClr val="FFFFFF"/>
-                    </a:solidFill>
-                  </a:tcPr>
-                </a:tc>
-                <a:tc>
-                  <a:txBody>
-                    <a:bodyPr/>
-                    <a:lstStyle/>
-                    <a:p>
-                      <a:r>
-                        <a:rPr sz="1500" b="0">
-                          <a:solidFill>
-                            <a:srgbClr val="0F2744"/>
-                          </a:solidFill>
-                          <a:latin typeface="Calibri"/>
-                        </a:rPr>
-                        <a:t>O(d_h) поэлементно</a:t>
-                      </a:r>
-                    </a:p>
-                  </a:txBody>
-                  <a:tcPr anchor="ctr">
-                    <a:solidFill>
-                      <a:srgbClr val="FFFFFF"/>
-                    </a:solidFill>
-                  </a:tcPr>
-                </a:tc>
-              </a:tr>
-            </a:tbl>
-          </a:graphicData>
-        </a:graphic>
-      </p:graphicFrame>
-      <p:sp>
-        <p:nvSpPr>
-          <p:cNvPr id="5" name="TextBox 4"/>
-          <p:cNvSpPr txBox="1"/>
-          <p:nvPr/>
-        </p:nvSpPr>
-        <p:spPr>
-          <a:xfrm>
-            <a:off x="502920" y="4800600"/>
-            <a:ext cx="11155680" cy="822960"/>
-          </a:xfrm>
-          <a:prstGeom prst="rect">
-            <a:avLst/>
-          </a:prstGeom>
-          <a:noFill/>
-        </p:spPr>
-        <p:txBody>
-          <a:bodyPr wrap="square">
-            <a:spAutoFit/>
-          </a:bodyPr>
-          <a:lstStyle/>
+              <a:t>• Компенсацию через MLP авторы заявляют, но на синтетических задачах проверена лишь Z₂-Parity, где межканальное смешивание не нужно.</a:t>
+            </a:r>
+          </a:p>
           <a:p>
             <a:pPr>
               <a:spcAft>
@@ -8250,7 +8054,7 @@
                 </a:solidFill>
                 <a:latin typeface="Calibri"/>
               </a:rPr>
-              <a:t>Time-mixing остаётся диагональной рекуррентностью, а channel-mixing выполняют слои MLP. Скан становится вычислительно дешёвым.</a:t>
+              <a:t>• Способна ли связка «1D-нелинейность + послойный MLP» заменить многомерную нелинейную динамику — в статье открытый вопрос.</a:t>
             </a:r>
           </a:p>
         </p:txBody>

</xml_diff>